<commit_message>
Clase: actualizar la trampa de códigos sin predecesor
Los SSD (8471.70.40) se resolvieron como partición de 8471.70.90 (commit 915daa4); la slide de trampas de aduana ya no los presenta como pendientes.

Co-Authored-By: Claude Opus 5.5 <noreply@anthropic.com>
Claude-Session: https://claude.ai/code/session_01U4R3nyu971cuK6Z9WbS5da
</commit_message>
<xml_diff>
--- a/clase/CIRTECAL_clase_metodo.pptx
+++ b/clase/CIRTECAL_clase_metodo.pptx
@@ -7052,7 +7052,7 @@
                 <a:ea typeface="Calibri" pitchFamily="34" charset="-122"/>
                 <a:cs typeface="Calibri" pitchFamily="34" charset="-120"/>
               </a:rPr>
-              <a:t>Códigos sin predecesor.  </a:t>
+              <a:t>Códigos que se parten.  </a:t>
             </a:r>
             <a:pPr indent="0" marL="0">
               <a:lnSpc>
@@ -7069,7 +7069,7 @@
                 <a:ea typeface="Calibri" pitchFamily="34" charset="-122"/>
                 <a:cs typeface="Calibri" pitchFamily="34" charset="-120"/>
               </a:rPr>
-              <a:t>8471.70.40 (SSD) y 9403.20.90 (racks): no leer crecimientos antes de resolverlos.</a:t>
+              <a:t>Los SSD (8471.70.40) nacen en 2024 de 8471.70.90: el «nuevo» código es una mudanza, no un crecimiento. Se leen sumados.</a:t>
             </a:r>
             <a:endParaRPr lang="en-US" sz="1150" dirty="0"/>
           </a:p>

</xml_diff>